<commit_message>
Lecture slides update according to LLVM version upgrade to 20
</commit_message>
<xml_diff>
--- a/3-clang-llvm/lec14-clang-vs-llvm-v2.pptx
+++ b/3-clang-llvm/lec14-clang-vs-llvm-v2.pptx
@@ -214,7 +214,7 @@
           <a:p>
             <a:fld id="{C7068FC9-2CB9-4F58-B590-0E9E9C60F171}" type="datetimeFigureOut">
               <a:rPr lang="ko-KR" altLang="en-US" smtClean="0"/>
-              <a:t>2023-04-27</a:t>
+              <a:t>2026-09-22</a:t>
             </a:fld>
             <a:endParaRPr lang="ko-KR" altLang="en-US"/>
           </a:p>
@@ -660,7 +660,7 @@
           <a:p>
             <a:fld id="{7FEC1E5B-1440-4A4A-8DF0-1C76AED34ED3}" type="datetime1">
               <a:rPr lang="ko-KR" altLang="en-US" smtClean="0"/>
-              <a:t>2023-04-27</a:t>
+              <a:t>2026-09-22</a:t>
             </a:fld>
             <a:endParaRPr lang="ko-KR" altLang="en-US"/>
           </a:p>
@@ -828,7 +828,7 @@
           <a:p>
             <a:fld id="{2D04A31D-7202-4B17-8E16-002C43DE5C00}" type="datetime1">
               <a:rPr lang="ko-KR" altLang="en-US" smtClean="0"/>
-              <a:t>2023-04-27</a:t>
+              <a:t>2026-09-22</a:t>
             </a:fld>
             <a:endParaRPr lang="ko-KR" altLang="en-US"/>
           </a:p>
@@ -1006,7 +1006,7 @@
           <a:p>
             <a:fld id="{F760A112-8C65-4C3A-B03A-E06521E1C1BC}" type="datetime1">
               <a:rPr lang="ko-KR" altLang="en-US" smtClean="0"/>
-              <a:t>2023-04-27</a:t>
+              <a:t>2026-09-22</a:t>
             </a:fld>
             <a:endParaRPr lang="ko-KR" altLang="en-US"/>
           </a:p>
@@ -1174,7 +1174,7 @@
           <a:p>
             <a:fld id="{D9290247-ED09-491E-9F92-3742F511CFC8}" type="datetime1">
               <a:rPr lang="ko-KR" altLang="en-US" smtClean="0"/>
-              <a:t>2023-04-27</a:t>
+              <a:t>2026-09-22</a:t>
             </a:fld>
             <a:endParaRPr lang="ko-KR" altLang="en-US"/>
           </a:p>
@@ -1419,7 +1419,7 @@
           <a:p>
             <a:fld id="{03F67775-ECFF-4A44-8BAD-15720A34ABC3}" type="datetime1">
               <a:rPr lang="ko-KR" altLang="en-US" smtClean="0"/>
-              <a:t>2023-04-27</a:t>
+              <a:t>2026-09-22</a:t>
             </a:fld>
             <a:endParaRPr lang="ko-KR" altLang="en-US"/>
           </a:p>
@@ -1704,7 +1704,7 @@
           <a:p>
             <a:fld id="{0BA8856C-C2BE-4981-BE8A-00CAC036F868}" type="datetime1">
               <a:rPr lang="ko-KR" altLang="en-US" smtClean="0"/>
-              <a:t>2023-04-27</a:t>
+              <a:t>2026-09-22</a:t>
             </a:fld>
             <a:endParaRPr lang="ko-KR" altLang="en-US"/>
           </a:p>
@@ -2123,7 +2123,7 @@
           <a:p>
             <a:fld id="{BC39B307-D33C-45BD-A159-11DB3B155C98}" type="datetime1">
               <a:rPr lang="ko-KR" altLang="en-US" smtClean="0"/>
-              <a:t>2023-04-27</a:t>
+              <a:t>2026-09-22</a:t>
             </a:fld>
             <a:endParaRPr lang="ko-KR" altLang="en-US"/>
           </a:p>
@@ -2240,7 +2240,7 @@
           <a:p>
             <a:fld id="{52B2340E-7067-4868-A810-2E66E459D1CD}" type="datetime1">
               <a:rPr lang="ko-KR" altLang="en-US" smtClean="0"/>
-              <a:t>2023-04-27</a:t>
+              <a:t>2026-09-22</a:t>
             </a:fld>
             <a:endParaRPr lang="ko-KR" altLang="en-US"/>
           </a:p>
@@ -2335,7 +2335,7 @@
           <a:p>
             <a:fld id="{BDA23144-ECEF-4D04-AEDE-5CFBE93D314E}" type="datetime1">
               <a:rPr lang="ko-KR" altLang="en-US" smtClean="0"/>
-              <a:t>2023-04-27</a:t>
+              <a:t>2026-09-22</a:t>
             </a:fld>
             <a:endParaRPr lang="ko-KR" altLang="en-US"/>
           </a:p>
@@ -2610,7 +2610,7 @@
           <a:p>
             <a:fld id="{3D76FA8D-8EF8-46F6-B0E3-0ABE0E4BBBCA}" type="datetime1">
               <a:rPr lang="ko-KR" altLang="en-US" smtClean="0"/>
-              <a:t>2023-04-27</a:t>
+              <a:t>2026-09-22</a:t>
             </a:fld>
             <a:endParaRPr lang="ko-KR" altLang="en-US"/>
           </a:p>
@@ -2862,7 +2862,7 @@
           <a:p>
             <a:fld id="{35966A0D-6E36-4F97-8697-CFF1DBB97C3B}" type="datetime1">
               <a:rPr lang="ko-KR" altLang="en-US" smtClean="0"/>
-              <a:t>2023-04-27</a:t>
+              <a:t>2026-09-22</a:t>
             </a:fld>
             <a:endParaRPr lang="ko-KR" altLang="en-US"/>
           </a:p>
@@ -3073,7 +3073,7 @@
           <a:p>
             <a:fld id="{F9C541EC-C1EF-4938-AE56-36A905BCF859}" type="datetime1">
               <a:rPr lang="ko-KR" altLang="en-US" smtClean="0"/>
-              <a:t>2023-04-27</a:t>
+              <a:t>2026-09-22</a:t>
             </a:fld>
             <a:endParaRPr lang="ko-KR" altLang="en-US"/>
           </a:p>
@@ -3557,7 +3557,7 @@
           <a:p>
             <a:fld id="{14346A74-6294-439E-95F4-12C1F180349B}" type="datetime1">
               <a:rPr lang="ko-KR" altLang="en-US" smtClean="0"/>
-              <a:t>2023-04-27</a:t>
+              <a:t>2026-09-22</a:t>
             </a:fld>
             <a:endParaRPr lang="ko-KR" altLang="en-US"/>
           </a:p>
@@ -4340,7 +4340,7 @@
               <a:rPr lang="ko-KR" altLang="en-US" smtClean="0">
                 <a:latin typeface="Calibri" panose="020F0502020204030204" pitchFamily="34" charset="0"/>
               </a:rPr>
-              <a:t>2023-04-27</a:t>
+              <a:t>2026-09-22</a:t>
             </a:fld>
             <a:endParaRPr lang="ko-KR" altLang="en-US">
               <a:latin typeface="Calibri" panose="020F0502020204030204" pitchFamily="34" charset="0"/>
@@ -4684,16 +4684,44 @@
                 <a:latin typeface="Courier New" panose="02070309020205020404" pitchFamily="49" charset="0"/>
                 <a:cs typeface="Courier New" panose="02070309020205020404" pitchFamily="49" charset="0"/>
               </a:rPr>
-              <a:t> 2   store i32 1, i32* %a</a:t>
-            </a:r>
-          </a:p>
-          <a:p>
-            <a:r>
-              <a:rPr lang="en-US" altLang="ko-KR" sz="1600" dirty="0">
-                <a:latin typeface="Courier New" panose="02070309020205020404" pitchFamily="49" charset="0"/>
-                <a:cs typeface="Courier New" panose="02070309020205020404" pitchFamily="49" charset="0"/>
-              </a:rPr>
-              <a:t> 3   %1 = load i32* %a</a:t>
+              <a:t> 2   store i32 1, </a:t>
+            </a:r>
+            <a:r>
+              <a:rPr lang="en-US" altLang="ko-KR" sz="1600" dirty="0" err="1">
+                <a:latin typeface="Courier New" panose="02070309020205020404" pitchFamily="49" charset="0"/>
+                <a:cs typeface="Courier New" panose="02070309020205020404" pitchFamily="49" charset="0"/>
+              </a:rPr>
+              <a:t>ptr</a:t>
+            </a:r>
+            <a:r>
+              <a:rPr lang="en-US" altLang="ko-KR" sz="1600" dirty="0">
+                <a:latin typeface="Courier New" panose="02070309020205020404" pitchFamily="49" charset="0"/>
+                <a:cs typeface="Courier New" panose="02070309020205020404" pitchFamily="49" charset="0"/>
+              </a:rPr>
+              <a:t> %a</a:t>
+            </a:r>
+          </a:p>
+          <a:p>
+            <a:r>
+              <a:rPr lang="en-US" altLang="ko-KR" sz="1600" dirty="0">
+                <a:latin typeface="Courier New" panose="02070309020205020404" pitchFamily="49" charset="0"/>
+                <a:cs typeface="Courier New" panose="02070309020205020404" pitchFamily="49" charset="0"/>
+              </a:rPr>
+              <a:t> 3   %1 = load i32, </a:t>
+            </a:r>
+            <a:r>
+              <a:rPr lang="en-US" altLang="ko-KR" sz="1600" dirty="0" err="1">
+                <a:latin typeface="Courier New" panose="02070309020205020404" pitchFamily="49" charset="0"/>
+                <a:cs typeface="Courier New" panose="02070309020205020404" pitchFamily="49" charset="0"/>
+              </a:rPr>
+              <a:t>ptr</a:t>
+            </a:r>
+            <a:r>
+              <a:rPr lang="en-US" altLang="ko-KR" sz="1600" dirty="0">
+                <a:latin typeface="Courier New" panose="02070309020205020404" pitchFamily="49" charset="0"/>
+                <a:cs typeface="Courier New" panose="02070309020205020404" pitchFamily="49" charset="0"/>
+              </a:rPr>
+              <a:t> %a</a:t>
             </a:r>
           </a:p>
           <a:p>
@@ -4711,16 +4739,44 @@
                 <a:latin typeface="Courier New" panose="02070309020205020404" pitchFamily="49" charset="0"/>
                 <a:cs typeface="Courier New" panose="02070309020205020404" pitchFamily="49" charset="0"/>
               </a:rPr>
-              <a:t> 5   store i32 %2, i32* %a</a:t>
-            </a:r>
-          </a:p>
-          <a:p>
-            <a:r>
-              <a:rPr lang="en-US" altLang="ko-KR" sz="1600" dirty="0">
-                <a:latin typeface="Courier New" panose="02070309020205020404" pitchFamily="49" charset="0"/>
-                <a:cs typeface="Courier New" panose="02070309020205020404" pitchFamily="49" charset="0"/>
-              </a:rPr>
-              <a:t> 6   %3 = load i32* %a</a:t>
+              <a:t> 5   store i32 %2, </a:t>
+            </a:r>
+            <a:r>
+              <a:rPr lang="en-US" altLang="ko-KR" sz="1600" dirty="0" err="1">
+                <a:latin typeface="Courier New" panose="02070309020205020404" pitchFamily="49" charset="0"/>
+                <a:cs typeface="Courier New" panose="02070309020205020404" pitchFamily="49" charset="0"/>
+              </a:rPr>
+              <a:t>ptr</a:t>
+            </a:r>
+            <a:r>
+              <a:rPr lang="en-US" altLang="ko-KR" sz="1600" dirty="0">
+                <a:latin typeface="Courier New" panose="02070309020205020404" pitchFamily="49" charset="0"/>
+                <a:cs typeface="Courier New" panose="02070309020205020404" pitchFamily="49" charset="0"/>
+              </a:rPr>
+              <a:t> %a</a:t>
+            </a:r>
+          </a:p>
+          <a:p>
+            <a:r>
+              <a:rPr lang="en-US" altLang="ko-KR" sz="1600" dirty="0">
+                <a:latin typeface="Courier New" panose="02070309020205020404" pitchFamily="49" charset="0"/>
+                <a:cs typeface="Courier New" panose="02070309020205020404" pitchFamily="49" charset="0"/>
+              </a:rPr>
+              <a:t> 6   %3 = load i32, </a:t>
+            </a:r>
+            <a:r>
+              <a:rPr lang="en-US" altLang="ko-KR" sz="1600" dirty="0" err="1">
+                <a:latin typeface="Courier New" panose="02070309020205020404" pitchFamily="49" charset="0"/>
+                <a:cs typeface="Courier New" panose="02070309020205020404" pitchFamily="49" charset="0"/>
+              </a:rPr>
+              <a:t>ptr</a:t>
+            </a:r>
+            <a:r>
+              <a:rPr lang="en-US" altLang="ko-KR" sz="1600" dirty="0">
+                <a:latin typeface="Courier New" panose="02070309020205020404" pitchFamily="49" charset="0"/>
+                <a:cs typeface="Courier New" panose="02070309020205020404" pitchFamily="49" charset="0"/>
+              </a:rPr>
+              <a:t> %a</a:t>
             </a:r>
           </a:p>
           <a:p>
@@ -4738,7 +4794,21 @@
                 <a:latin typeface="Courier New" panose="02070309020205020404" pitchFamily="49" charset="0"/>
                 <a:cs typeface="Courier New" panose="02070309020205020404" pitchFamily="49" charset="0"/>
               </a:rPr>
-              <a:t> 8   store i32 %4, i32* %a</a:t>
+              <a:t> 8   store i32 %4, </a:t>
+            </a:r>
+            <a:r>
+              <a:rPr lang="en-US" altLang="ko-KR" sz="1600" dirty="0" err="1">
+                <a:latin typeface="Courier New" panose="02070309020205020404" pitchFamily="49" charset="0"/>
+                <a:cs typeface="Courier New" panose="02070309020205020404" pitchFamily="49" charset="0"/>
+              </a:rPr>
+              <a:t>ptr</a:t>
+            </a:r>
+            <a:r>
+              <a:rPr lang="en-US" altLang="ko-KR" sz="1600" dirty="0">
+                <a:latin typeface="Courier New" panose="02070309020205020404" pitchFamily="49" charset="0"/>
+                <a:cs typeface="Courier New" panose="02070309020205020404" pitchFamily="49" charset="0"/>
+              </a:rPr>
+              <a:t> %a</a:t>
             </a:r>
           </a:p>
           <a:p>
@@ -4756,16 +4826,44 @@
                 <a:latin typeface="Courier New" panose="02070309020205020404" pitchFamily="49" charset="0"/>
                 <a:cs typeface="Courier New" panose="02070309020205020404" pitchFamily="49" charset="0"/>
               </a:rPr>
-              <a:t>10   store i32 %5, i32* %b</a:t>
-            </a:r>
-          </a:p>
-          <a:p>
-            <a:r>
-              <a:rPr lang="en-US" altLang="ko-KR" sz="1600" dirty="0">
-                <a:latin typeface="Courier New" panose="02070309020205020404" pitchFamily="49" charset="0"/>
-                <a:cs typeface="Courier New" panose="02070309020205020404" pitchFamily="49" charset="0"/>
-              </a:rPr>
-              <a:t>11   %6 = load i32* %b</a:t>
+              <a:t>10   store i32 %5, </a:t>
+            </a:r>
+            <a:r>
+              <a:rPr lang="en-US" altLang="ko-KR" sz="1600" dirty="0" err="1">
+                <a:latin typeface="Courier New" panose="02070309020205020404" pitchFamily="49" charset="0"/>
+                <a:cs typeface="Courier New" panose="02070309020205020404" pitchFamily="49" charset="0"/>
+              </a:rPr>
+              <a:t>ptr</a:t>
+            </a:r>
+            <a:r>
+              <a:rPr lang="en-US" altLang="ko-KR" sz="1600" dirty="0">
+                <a:latin typeface="Courier New" panose="02070309020205020404" pitchFamily="49" charset="0"/>
+                <a:cs typeface="Courier New" panose="02070309020205020404" pitchFamily="49" charset="0"/>
+              </a:rPr>
+              <a:t> %b</a:t>
+            </a:r>
+          </a:p>
+          <a:p>
+            <a:r>
+              <a:rPr lang="en-US" altLang="ko-KR" sz="1600" dirty="0">
+                <a:latin typeface="Courier New" panose="02070309020205020404" pitchFamily="49" charset="0"/>
+                <a:cs typeface="Courier New" panose="02070309020205020404" pitchFamily="49" charset="0"/>
+              </a:rPr>
+              <a:t>11   %6 = load i32, </a:t>
+            </a:r>
+            <a:r>
+              <a:rPr lang="en-US" altLang="ko-KR" sz="1600" dirty="0" err="1">
+                <a:latin typeface="Courier New" panose="02070309020205020404" pitchFamily="49" charset="0"/>
+                <a:cs typeface="Courier New" panose="02070309020205020404" pitchFamily="49" charset="0"/>
+              </a:rPr>
+              <a:t>ptr</a:t>
+            </a:r>
+            <a:r>
+              <a:rPr lang="en-US" altLang="ko-KR" sz="1600" dirty="0">
+                <a:latin typeface="Courier New" panose="02070309020205020404" pitchFamily="49" charset="0"/>
+                <a:cs typeface="Courier New" panose="02070309020205020404" pitchFamily="49" charset="0"/>
+              </a:rPr>
+              <a:t> %b</a:t>
             </a:r>
           </a:p>
           <a:p>
@@ -4842,7 +4940,7 @@
           <a:p>
             <a:fld id="{2F2AAAB7-6ED6-42E5-9B61-97F35BB021DD}" type="datetime1">
               <a:rPr lang="ko-KR" altLang="en-US" smtClean="0"/>
-              <a:t>2023-04-27</a:t>
+              <a:t>2026-09-22</a:t>
             </a:fld>
             <a:endParaRPr lang="ko-KR" altLang="en-US"/>
           </a:p>
@@ -5148,7 +5246,7 @@
           <a:p>
             <a:fld id="{2F2AAAB7-6ED6-42E5-9B61-97F35BB021DD}" type="datetime1">
               <a:rPr lang="ko-KR" altLang="en-US" smtClean="0"/>
-              <a:t>2023-04-27</a:t>
+              <a:t>2026-09-22</a:t>
             </a:fld>
             <a:endParaRPr lang="ko-KR" altLang="en-US"/>
           </a:p>
@@ -5820,7 +5918,7 @@
           <a:p>
             <a:fld id="{2F2AAAB7-6ED6-42E5-9B61-97F35BB021DD}" type="datetime1">
               <a:rPr lang="ko-KR" altLang="en-US" smtClean="0"/>
-              <a:t>2023-04-27</a:t>
+              <a:t>2026-09-22</a:t>
             </a:fld>
             <a:endParaRPr lang="ko-KR" altLang="en-US"/>
           </a:p>
@@ -6537,7 +6635,7 @@
           <a:p>
             <a:fld id="{2F2AAAB7-6ED6-42E5-9B61-97F35BB021DD}" type="datetime1">
               <a:rPr lang="ko-KR" altLang="en-US" smtClean="0"/>
-              <a:t>2023-04-27</a:t>
+              <a:t>2026-09-22</a:t>
             </a:fld>
             <a:endParaRPr lang="ko-KR" altLang="en-US"/>
           </a:p>
@@ -6890,7 +6988,7 @@
                 <a:latin typeface="Courier New" panose="02070309020205020404" pitchFamily="49" charset="0"/>
                 <a:cs typeface="Courier New" panose="02070309020205020404" pitchFamily="49" charset="0"/>
               </a:rPr>
-              <a:t> [10 x i32]* </a:t>
+              <a:t> [10 x i32], </a:t>
             </a:r>
           </a:p>
           <a:p>
@@ -6899,7 +6997,21 @@
                 <a:latin typeface="Courier New" panose="02070309020205020404" pitchFamily="49" charset="0"/>
                 <a:cs typeface="Courier New" panose="02070309020205020404" pitchFamily="49" charset="0"/>
               </a:rPr>
-              <a:t>            </a:t>
+              <a:t>           </a:t>
+            </a:r>
+            <a:r>
+              <a:rPr lang="en-US" altLang="ko-KR" sz="1400" dirty="0" err="1">
+                <a:latin typeface="Courier New" panose="02070309020205020404" pitchFamily="49" charset="0"/>
+                <a:cs typeface="Courier New" panose="02070309020205020404" pitchFamily="49" charset="0"/>
+              </a:rPr>
+              <a:t>ptr</a:t>
+            </a:r>
+            <a:r>
+              <a:rPr lang="en-US" altLang="ko-KR" sz="1400" dirty="0">
+                <a:latin typeface="Courier New" panose="02070309020205020404" pitchFamily="49" charset="0"/>
+                <a:cs typeface="Courier New" panose="02070309020205020404" pitchFamily="49" charset="0"/>
+              </a:rPr>
+              <a:t> </a:t>
             </a:r>
             <a:r>
               <a:rPr lang="en-US" altLang="ko-KR" sz="1400" b="1" dirty="0">
@@ -6992,7 +7104,7 @@
                 <a:latin typeface="Courier New" panose="02070309020205020404" pitchFamily="49" charset="0"/>
                 <a:cs typeface="Courier New" panose="02070309020205020404" pitchFamily="49" charset="0"/>
               </a:rPr>
-              <a:t>[10 x i32]* </a:t>
+              <a:t>[10 x i32], </a:t>
             </a:r>
           </a:p>
           <a:p>
@@ -7002,6 +7114,20 @@
                 <a:cs typeface="Courier New" panose="02070309020205020404" pitchFamily="49" charset="0"/>
               </a:rPr>
               <a:t>            </a:t>
+            </a:r>
+            <a:r>
+              <a:rPr lang="en-US" altLang="ko-KR" sz="1400" dirty="0" err="1">
+                <a:latin typeface="Courier New" panose="02070309020205020404" pitchFamily="49" charset="0"/>
+                <a:cs typeface="Courier New" panose="02070309020205020404" pitchFamily="49" charset="0"/>
+              </a:rPr>
+              <a:t>ptr</a:t>
+            </a:r>
+            <a:r>
+              <a:rPr lang="en-US" altLang="ko-KR" sz="1400" dirty="0">
+                <a:latin typeface="Courier New" panose="02070309020205020404" pitchFamily="49" charset="0"/>
+                <a:cs typeface="Courier New" panose="02070309020205020404" pitchFamily="49" charset="0"/>
+              </a:rPr>
+              <a:t> </a:t>
             </a:r>
             <a:r>
               <a:rPr lang="en-US" altLang="ko-KR" sz="1400" b="1" dirty="0">
@@ -7268,7 +7394,7 @@
           <a:p>
             <a:fld id="{D9290247-ED09-491E-9F92-3742F511CFC8}" type="datetime1">
               <a:rPr lang="ko-KR" altLang="en-US" smtClean="0"/>
-              <a:t>2023-04-27</a:t>
+              <a:t>2026-09-22</a:t>
             </a:fld>
             <a:endParaRPr lang="ko-KR" altLang="en-US"/>
           </a:p>

</xml_diff>